<commit_message>
Add report as docx and pdf, put the live link on the deck
</commit_message>
<xml_diff>
--- a/deck/Hybrid_Movie_Recommender.pptx
+++ b/deck/Hybrid_Movie_Recommender.pptx
@@ -118,13 +118,13 @@
   <p:extLst>
     <p:ext uri="{521415D9-36F7-43E2-AB2F-B90AF26B5E84}">
       <p14:sectionLst xmlns:p14="http://schemas.microsoft.com/office/powerpoint/2010/main">
-        <p14:section name="Intro" id="{7705a683-d51a-eb72-7838-e656425cf7e9}">
+        <p14:section name="Intro" id="{1cc576bb-8376-40da-b661-7f41d083609e}">
           <p14:sldIdLst>
             <p14:sldId id="256"/>
             <p14:sldId id="257"/>
           </p14:sldIdLst>
         </p14:section>
-        <p14:section name="Method" id="{9ee8fa87-53aa-381c-b1d5-84009d5af5af}">
+        <p14:section name="Method" id="{15f73107-5db1-3674-9f3e-ba67afa17f28}">
           <p14:sldIdLst>
             <p14:sldId id="258"/>
             <p14:sldId id="259"/>
@@ -132,19 +132,19 @@
             <p14:sldId id="261"/>
           </p14:sldIdLst>
         </p14:section>
-        <p14:section name="Results" id="{6018a285-5967-6798-201d-82fda5cb0daf}">
+        <p14:section name="Results" id="{1bbaa194-0d4b-0e41-8d4d-0a84cb896088}">
           <p14:sldIdLst>
             <p14:sldId id="262"/>
             <p14:sldId id="263"/>
             <p14:sldId id="264"/>
           </p14:sldIdLst>
         </p14:section>
-        <p14:section name="Demo" id="{b4eb665c-7bdc-8896-89da-25890f8a056f}">
+        <p14:section name="Demo" id="{40814c14-d9da-f960-491f-d0b0c4673f0f}">
           <p14:sldIdLst>
             <p14:sldId id="265"/>
           </p14:sldIdLst>
         </p14:section>
-        <p14:section name="Wrap-up" id="{e8c598c7-a6b5-fbe8-fd95-2401944ed1cd}">
+        <p14:section name="Wrap-up" id="{cd4b3b2d-5ca0-2cc1-2922-4a2cfe4a8ac4}">
           <p14:sldIdLst>
             <p14:sldId id="266"/>
             <p14:sldId id="267"/>
@@ -4033,12 +4033,34 @@
               <a:buNone/>
             </a:pPr>
             <a:r>
+              <a:rPr lang="en-US" sz="1200" b="1" dirty="0">
+                <a:solidFill>
+                  <a:schemeClr val="accent5"/>
+                </a:solidFill>
+              </a:rPr>
+              <a:t>Live: </a:t>
+            </a:r>
+            <a:pPr indent="0" marL="0">
+              <a:buNone/>
+            </a:pPr>
+            <a:r>
               <a:rPr lang="en-US" sz="1200" dirty="0">
                 <a:solidFill>
                   <a:schemeClr val="accent5"/>
                 </a:solidFill>
               </a:rPr>
-              <a:t>Run live: streamlit run app.py. Click Like or Not for me and the row re-ranks at once.</a:t>
+              <a:t>sahil-u07-hybrid-movie-recommender-app-dqy8sx.streamlit.app</a:t>
+            </a:r>
+            <a:pPr indent="0" marL="0">
+              <a:buNone/>
+            </a:pPr>
+            <a:r>
+              <a:rPr lang="en-US" sz="1200" dirty="0">
+                <a:solidFill>
+                  <a:schemeClr val="accent5"/>
+                </a:solidFill>
+              </a:rPr>
+              <a:t>   ·   Click Like or Not for me and the row re-ranks at once.</a:t>
             </a:r>
             <a:endParaRPr lang="en-US" sz="1200" dirty="0"/>
           </a:p>
@@ -4631,8 +4653,8 @@
         </p:nvSpPr>
         <p:spPr>
           <a:xfrm>
-            <a:off x="548640" y="3200400"/>
-            <a:ext cx="5943600" cy="548640"/>
+            <a:off x="548640" y="3154680"/>
+            <a:ext cx="6583680" cy="822960"/>
           </a:xfrm>
           <a:prstGeom prst="rect">
             <a:avLst/>
@@ -4645,6 +4667,23 @@
           <a:lstStyle/>
           <a:p>
             <a:pPr indent="0" marL="0">
+              <a:spcAft>
+                <a:spcPts val="400"/>
+              </a:spcAft>
+              <a:buNone/>
+            </a:pPr>
+            <a:r>
+              <a:rPr lang="en-US" sz="1400" b="1" dirty="0">
+                <a:solidFill>
+                  <a:schemeClr val="accent6"/>
+                </a:solidFill>
+              </a:rPr>
+              <a:t>Live app:  </a:t>
+            </a:r>
+            <a:pPr indent="0" marL="0">
+              <a:spcAft>
+                <a:spcPts val="400"/>
+              </a:spcAft>
               <a:buNone/>
             </a:pPr>
             <a:r>
@@ -4653,7 +4692,38 @@
                   <a:schemeClr val="accent6"/>
                 </a:solidFill>
               </a:rPr>
-              <a:t>Code, tests and evaluation: python eval.py, python -m pytest, streamlit run app.py</a:t>
+              <a:t>sahil-u07-hybrid-movie-recommender-app-dqy8sx.streamlit.app</a:t>
+            </a:r>
+            <a:endParaRPr lang="en-US" sz="1400" dirty="0"/>
+          </a:p>
+          <a:p>
+            <a:pPr indent="0" marL="0">
+              <a:spcAft>
+                <a:spcPts val="400"/>
+              </a:spcAft>
+              <a:buNone/>
+            </a:pPr>
+            <a:r>
+              <a:rPr lang="en-US" sz="1400" b="1" dirty="0">
+                <a:solidFill>
+                  <a:schemeClr val="accent6"/>
+                </a:solidFill>
+              </a:rPr>
+              <a:t>Code:  </a:t>
+            </a:r>
+            <a:pPr indent="0" marL="0">
+              <a:spcAft>
+                <a:spcPts val="400"/>
+              </a:spcAft>
+              <a:buNone/>
+            </a:pPr>
+            <a:r>
+              <a:rPr lang="en-US" sz="1400" dirty="0">
+                <a:solidFill>
+                  <a:schemeClr val="accent6"/>
+                </a:solidFill>
+              </a:rPr>
+              <a:t>github.com/Sahil-u07/hybrid-movie-recommender</a:t>
             </a:r>
             <a:endParaRPr lang="en-US" sz="1400" dirty="0"/>
           </a:p>

</xml_diff>

<commit_message>
Add both authors with registration numbers to the deck, README and report
</commit_message>
<xml_diff>
--- a/deck/Hybrid_Movie_Recommender.pptx
+++ b/deck/Hybrid_Movie_Recommender.pptx
@@ -118,13 +118,13 @@
   <p:extLst>
     <p:ext uri="{521415D9-36F7-43E2-AB2F-B90AF26B5E84}">
       <p14:sectionLst xmlns:p14="http://schemas.microsoft.com/office/powerpoint/2010/main">
-        <p14:section name="Intro" id="{1cc576bb-8376-40da-b661-7f41d083609e}">
+        <p14:section name="Intro" id="{5f20b27f-e16c-6c43-97d4-82d411a3ccc3}">
           <p14:sldIdLst>
             <p14:sldId id="256"/>
             <p14:sldId id="257"/>
           </p14:sldIdLst>
         </p14:section>
-        <p14:section name="Method" id="{15f73107-5db1-3674-9f3e-ba67afa17f28}">
+        <p14:section name="Method" id="{e24487cb-e4ce-18b9-9262-9ddd03c4835f}">
           <p14:sldIdLst>
             <p14:sldId id="258"/>
             <p14:sldId id="259"/>
@@ -132,19 +132,19 @@
             <p14:sldId id="261"/>
           </p14:sldIdLst>
         </p14:section>
-        <p14:section name="Results" id="{1bbaa194-0d4b-0e41-8d4d-0a84cb896088}">
+        <p14:section name="Results" id="{db5e2a1b-e2bb-9f01-0d54-c8c3e818ec4a}">
           <p14:sldIdLst>
             <p14:sldId id="262"/>
             <p14:sldId id="263"/>
             <p14:sldId id="264"/>
           </p14:sldIdLst>
         </p14:section>
-        <p14:section name="Demo" id="{40814c14-d9da-f960-491f-d0b0c4673f0f}">
+        <p14:section name="Demo" id="{923fb1be-d1b3-6b48-2b7f-65b9a415deae}">
           <p14:sldIdLst>
             <p14:sldId id="265"/>
           </p14:sldIdLst>
         </p14:section>
-        <p14:section name="Wrap-up" id="{cd4b3b2d-5ca0-2cc1-2922-4a2cfe4a8ac4}">
+        <p14:section name="Wrap-up" id="{642cb7a2-17bb-a04b-083a-b7999623fa83}">
           <p14:sldIdLst>
             <p14:sldId id="266"/>
             <p14:sldId id="267"/>
@@ -2919,8 +2919,8 @@
         </p:nvSpPr>
         <p:spPr>
           <a:xfrm>
-            <a:off x="548640" y="3840480"/>
-            <a:ext cx="5486400" cy="365760"/>
+            <a:off x="548640" y="3611880"/>
+            <a:ext cx="5486400" cy="685800"/>
           </a:xfrm>
           <a:prstGeom prst="rect">
             <a:avLst/>
@@ -2929,21 +2929,41 @@
           <a:ln/>
         </p:spPr>
         <p:txBody>
-          <a:bodyPr wrap="square" lIns="0" tIns="0" rIns="0" bIns="0" rtlCol="0" anchor="ctr"/>
+          <a:bodyPr wrap="square" lIns="0" tIns="0" rIns="0" bIns="0" rtlCol="0" anchor="t"/>
           <a:lstStyle/>
           <a:p>
             <a:pPr indent="0" marL="0">
+              <a:spcAft>
+                <a:spcPts val="200"/>
+              </a:spcAft>
               <a:buNone/>
             </a:pPr>
             <a:r>
-              <a:rPr lang="en-US" sz="1800" b="1" dirty="0">
+              <a:rPr lang="en-US" sz="1700" b="1" dirty="0">
                 <a:solidFill>
                   <a:schemeClr val="accent2"/>
                 </a:solidFill>
               </a:rPr>
-              <a:t>Sahil Lenka and Kanishk Shukla</a:t>
+              <a:t>Sahil Lenka  ·  2427010391</a:t>
             </a:r>
-            <a:endParaRPr lang="en-US" sz="1800" dirty="0"/>
+            <a:endParaRPr lang="en-US" sz="1700" dirty="0"/>
+          </a:p>
+          <a:p>
+            <a:pPr indent="0" marL="0">
+              <a:spcAft>
+                <a:spcPts val="200"/>
+              </a:spcAft>
+              <a:buNone/>
+            </a:pPr>
+            <a:r>
+              <a:rPr lang="en-US" sz="1700" b="1" dirty="0">
+                <a:solidFill>
+                  <a:schemeClr val="accent2"/>
+                </a:solidFill>
+              </a:rPr>
+              <a:t>Kanishk Shukla  ·  2427010432</a:t>
+            </a:r>
+            <a:endParaRPr lang="en-US" sz="1700" dirty="0"/>
           </a:p>
         </p:txBody>
       </p:sp>
@@ -4617,8 +4637,8 @@
         </p:nvSpPr>
         <p:spPr>
           <a:xfrm>
-            <a:off x="548640" y="2651760"/>
-            <a:ext cx="5486400" cy="365760"/>
+            <a:off x="548640" y="2514600"/>
+            <a:ext cx="5486400" cy="685800"/>
           </a:xfrm>
           <a:prstGeom prst="rect">
             <a:avLst/>
@@ -4627,21 +4647,41 @@
           <a:ln/>
         </p:spPr>
         <p:txBody>
-          <a:bodyPr wrap="square" lIns="0" tIns="0" rIns="0" bIns="0" rtlCol="0" anchor="ctr"/>
+          <a:bodyPr wrap="square" lIns="0" tIns="0" rIns="0" bIns="0" rtlCol="0" anchor="t"/>
           <a:lstStyle/>
           <a:p>
             <a:pPr indent="0" marL="0">
+              <a:spcAft>
+                <a:spcPts val="200"/>
+              </a:spcAft>
               <a:buNone/>
             </a:pPr>
             <a:r>
-              <a:rPr lang="en-US" sz="1800" b="1" dirty="0">
+              <a:rPr lang="en-US" sz="1700" b="1" dirty="0">
                 <a:solidFill>
                   <a:schemeClr val="accent2"/>
                 </a:solidFill>
               </a:rPr>
-              <a:t>Sahil Lenka and Kanishk Shukla</a:t>
+              <a:t>Sahil Lenka  ·  2427010391</a:t>
             </a:r>
-            <a:endParaRPr lang="en-US" sz="1800" dirty="0"/>
+            <a:endParaRPr lang="en-US" sz="1700" dirty="0"/>
+          </a:p>
+          <a:p>
+            <a:pPr indent="0" marL="0">
+              <a:spcAft>
+                <a:spcPts val="200"/>
+              </a:spcAft>
+              <a:buNone/>
+            </a:pPr>
+            <a:r>
+              <a:rPr lang="en-US" sz="1700" b="1" dirty="0">
+                <a:solidFill>
+                  <a:schemeClr val="accent2"/>
+                </a:solidFill>
+              </a:rPr>
+              <a:t>Kanishk Shukla  ·  2427010432</a:t>
+            </a:r>
+            <a:endParaRPr lang="en-US" sz="1700" dirty="0"/>
           </a:p>
         </p:txBody>
       </p:sp>

</xml_diff>

<commit_message>
Add screenshots, a detailed PDF report and a screenshots slide
Report.pdf is generated from the real evaluation output and screenshots of the
deployed app. The deck gains a slide showing the running interface.
</commit_message>
<xml_diff>
--- a/deck/Hybrid_Movie_Recommender.pptx
+++ b/deck/Hybrid_Movie_Recommender.pptx
@@ -17,9 +17,10 @@
     <p:sldId id="265" r:id="rId11"/>
     <p:sldId id="266" r:id="rId12"/>
     <p:sldId id="267" r:id="rId13"/>
+    <p:sldId id="268" r:id="rId14"/>
   </p:sldIdLst>
   <p:notesMasterIdLst>
-    <p:notesMasterId r:id="rId14"/>
+    <p:notesMasterId r:id="rId15"/>
   </p:notesMasterIdLst>
   <p:sldSz cx="9144000" cy="5143500"/>
   <p:notesSz cx="5143500" cy="9144000"/>
@@ -118,13 +119,13 @@
   <p:extLst>
     <p:ext uri="{521415D9-36F7-43E2-AB2F-B90AF26B5E84}">
       <p14:sectionLst xmlns:p14="http://schemas.microsoft.com/office/powerpoint/2010/main">
-        <p14:section name="Intro" id="{5f20b27f-e16c-6c43-97d4-82d411a3ccc3}">
+        <p14:section name="Intro" id="{bfdacdf8-9a15-3f06-4979-635f47438073}">
           <p14:sldIdLst>
             <p14:sldId id="256"/>
             <p14:sldId id="257"/>
           </p14:sldIdLst>
         </p14:section>
-        <p14:section name="Method" id="{e24487cb-e4ce-18b9-9262-9ddd03c4835f}">
+        <p14:section name="Method" id="{ab0b9eb8-c3fd-4ff7-e919-c0a59f825e3d}">
           <p14:sldIdLst>
             <p14:sldId id="258"/>
             <p14:sldId id="259"/>
@@ -132,22 +133,23 @@
             <p14:sldId id="261"/>
           </p14:sldIdLst>
         </p14:section>
-        <p14:section name="Results" id="{db5e2a1b-e2bb-9f01-0d54-c8c3e818ec4a}">
+        <p14:section name="Results" id="{8bca3ef9-68c2-3ec5-7b67-600a531a9e6e}">
           <p14:sldIdLst>
             <p14:sldId id="262"/>
             <p14:sldId id="263"/>
             <p14:sldId id="264"/>
           </p14:sldIdLst>
         </p14:section>
-        <p14:section name="Demo" id="{923fb1be-d1b3-6b48-2b7f-65b9a415deae}">
+        <p14:section name="Demo" id="{9180faf0-91e1-778b-2a9a-c082e8de05c4}">
           <p14:sldIdLst>
             <p14:sldId id="265"/>
+            <p14:sldId id="266"/>
           </p14:sldIdLst>
         </p14:section>
-        <p14:section name="Wrap-up" id="{642cb7a2-17bb-a04b-083a-b7999623fa83}">
+        <p14:section name="Wrap-up" id="{1f809110-df9e-9260-ddc2-0690c0706f61}">
           <p14:sldIdLst>
-            <p14:sldId id="266"/>
             <p14:sldId id="267"/>
+            <p14:sldId id="268"/>
           </p14:sldIdLst>
         </p14:section>
       </p14:sectionLst>
@@ -1377,7 +1379,7 @@
           <a:p>
             <a:r>
               <a:rPr lang="en-US" dirty="0"/>
-              <a:t>Keep this short and direct. We claim a clear improvement over popularity and over content similarity, a working cold-start path, explanations tied to the real score, and a user-controlled diversity dial. We do not claim to beat collaborative filtering on accuracy, and we missed the coverage target. The full product in the spec is future work.</a:t>
+              <a:t>These are screenshots of the deployed app, not mockups. Open the live link if the room has internet; the address is on the previous slide and on the last slide. Point out that every card states why it was picked, and that the breakdown behind Why this? is the same number the ranking used.</a:t>
             </a:r>
             <a:endParaRPr lang="en-US" dirty="0"/>
           </a:p>
@@ -1465,7 +1467,7 @@
           <a:p>
             <a:r>
               <a:rPr lang="en-US" dirty="0"/>
-              <a:t>Likely viva questions. Why hybrid? Each single method fails somewhere: content needs liked films, collaborative needs ratings, popularity is identical for everyone. The stage-based weights let whichever signal has data lead. How is cold start handled? No input gives popular well-rated films; a quiz gives preference plus content similarity to the picked favourites; collaborative weight is zero in the cold stage and grows as ratings arrive. What does NDCG measure? How high the liked films appear in the top ten, with higher positions worth more, normalised by the best possible ordering. Why does diversity need its own step? Score ranking alone returns near-duplicates; MMR subtracts similarity to what is already chosen. Why did the spec weights lose? They were untuned starting values and gave too much weight to genre preference and content, which are weak predictors on this data.</a:t>
+              <a:t>Keep this short and direct. We claim a clear improvement over popularity and over content similarity, a working cold-start path, explanations tied to the real score, and a user-controlled diversity dial. We do not claim to beat collaborative filtering on accuracy, and we missed the coverage target. The full product in the spec is future work.</a:t>
             </a:r>
             <a:endParaRPr lang="en-US" dirty="0"/>
           </a:p>
@@ -1489,6 +1491,94 @@
             <a:fld id="{F7021451-1387-4CA6-816F-3879F97B5CBC}" type="slidenum">
               <a:rPr lang="en-US"/>
               <a:t>12</a:t>
+            </a:fld>
+            <a:endParaRPr lang="en-US"/>
+          </a:p>
+        </p:txBody>
+      </p:sp>
+    </p:spTree>
+    <p:extLst>
+      <p:ext uri="{BB962C8B-B14F-4D97-AF65-F5344CB8AC3E}">
+        <p14:creationId xmlns:p14="http://schemas.microsoft.com/office/powerpoint/2010/main" val="1024086991"/>
+      </p:ext>
+    </p:extLst>
+  </p:cSld>
+  <p:clrMapOvr>
+    <a:masterClrMapping/>
+  </p:clrMapOvr>
+</p:notes>
+</file>
+
+<file path=ppt/notesSlides/notesSlide13.xml><?xml version="1.0" encoding="utf-8"?>
+<p:notes xmlns:a="http://schemas.openxmlformats.org/drawingml/2006/main" xmlns:r="http://schemas.openxmlformats.org/officeDocument/2006/relationships" xmlns:p="http://schemas.openxmlformats.org/presentationml/2006/main">
+  <p:cSld>
+    <p:spTree>
+      <p:nvGrpSpPr>
+        <p:cNvPr id="1" name=""/>
+        <p:cNvGrpSpPr/>
+        <p:nvPr/>
+      </p:nvGrpSpPr>
+      <p:grpSpPr>
+        <a:xfrm>
+          <a:off x="0" y="0"/>
+          <a:ext cx="0" cy="0"/>
+          <a:chOff x="0" y="0"/>
+          <a:chExt cx="0" cy="0"/>
+        </a:xfrm>
+      </p:grpSpPr>
+      <p:sp>
+        <p:nvSpPr>
+          <p:cNvPr id="2" name="Slide Image Placeholder 1"/>
+          <p:cNvSpPr>
+            <a:spLocks noGrp="1" noRot="1" noChangeAspect="1"/>
+          </p:cNvSpPr>
+          <p:nvPr>
+            <p:ph type="sldImg"/>
+          </p:nvPr>
+        </p:nvSpPr>
+        <p:spPr/>
+      </p:sp>
+      <p:sp>
+        <p:nvSpPr>
+          <p:cNvPr id="3" name="Notes Placeholder 2"/>
+          <p:cNvSpPr>
+            <a:spLocks noGrp="1"/>
+          </p:cNvSpPr>
+          <p:nvPr>
+            <p:ph type="body" idx="1"/>
+          </p:nvPr>
+        </p:nvSpPr>
+        <p:spPr/>
+        <p:txBody>
+          <a:bodyPr/>
+          <a:lstStyle/>
+          <a:p>
+            <a:r>
+              <a:rPr lang="en-US" dirty="0"/>
+              <a:t>Likely viva questions. Why hybrid? Each single method fails somewhere: content needs liked films, collaborative needs ratings, popularity is identical for everyone. The stage-based weights let whichever signal has data lead. How is cold start handled? No input gives popular well-rated films; a quiz gives preference plus content similarity to the picked favourites; collaborative weight is zero in the cold stage and grows as ratings arrive. What does NDCG measure? How high the liked films appear in the top ten, with higher positions worth more, normalised by the best possible ordering. Why does diversity need its own step? Score ranking alone returns near-duplicates; MMR subtracts similarity to what is already chosen. Why did the spec weights lose? They were untuned starting values and gave too much weight to genre preference and content, which are weak predictors on this data.</a:t>
+            </a:r>
+            <a:endParaRPr lang="en-US" dirty="0"/>
+          </a:p>
+        </p:txBody>
+      </p:sp>
+      <p:sp>
+        <p:nvSpPr>
+          <p:cNvPr id="4" name="Slide Number Placeholder 3"/>
+          <p:cNvSpPr>
+            <a:spLocks noGrp="1"/>
+          </p:cNvSpPr>
+          <p:nvPr>
+            <p:ph type="sldNum" sz="quarter" idx="10"/>
+          </p:nvPr>
+        </p:nvSpPr>
+        <p:spPr/>
+        <p:txBody>
+          <a:bodyPr/>
+          <a:lstStyle/>
+          <a:p>
+            <a:fld id="{F7021451-1387-4CA6-816F-3879F97B5CBC}" type="slidenum">
+              <a:rPr lang="en-US"/>
+              <a:t>13</a:t>
             </a:fld>
             <a:endParaRPr lang="en-US"/>
           </a:p>
@@ -4188,6 +4278,354 @@
                   <a:schemeClr val="tx2"/>
                 </a:solidFill>
               </a:rPr>
+              <a:t>The app itself</a:t>
+            </a:r>
+            <a:endParaRPr lang="en-US" sz="3200" dirty="0"/>
+          </a:p>
+        </p:txBody>
+      </p:sp>
+      <p:pic>
+        <p:nvPicPr>
+          <p:cNvPr id="3" name="Screenshot 1" descr="/home/claude/hybrid-movie-recommender/docs/screenshots/01-quiz.jpg">    </p:cNvPr>
+          <p:cNvPicPr>
+            <a:picLocks noChangeAspect="1"/>
+          </p:cNvPicPr>
+          <p:nvPr/>
+        </p:nvPicPr>
+        <p:blipFill>
+          <a:blip r:embed="rId1"/>
+          <a:stretch>
+            <a:fillRect/>
+          </a:stretch>
+        </p:blipFill>
+        <p:spPr>
+          <a:xfrm>
+            <a:off x="640080" y="1078992"/>
+            <a:ext cx="3456432" cy="1463040"/>
+          </a:xfrm>
+          <a:prstGeom prst="rect">
+            <a:avLst/>
+          </a:prstGeom>
+        </p:spPr>
+      </p:pic>
+      <p:sp>
+        <p:nvSpPr>
+          <p:cNvPr id="4" name="Text 1"/>
+          <p:cNvSpPr txBox="1"/>
+          <p:nvPr/>
+        </p:nvSpPr>
+        <p:spPr>
+          <a:xfrm>
+            <a:off x="640080" y="2569464"/>
+            <a:ext cx="3456432" cy="274320"/>
+          </a:xfrm>
+          <a:prstGeom prst="rect">
+            <a:avLst/>
+          </a:prstGeom>
+          <a:noFill/>
+          <a:ln/>
+        </p:spPr>
+        <p:txBody>
+          <a:bodyPr wrap="square" lIns="0" tIns="0" rIns="0" bIns="0" rtlCol="0" anchor="t"/>
+          <a:lstStyle/>
+          <a:p>
+            <a:pPr indent="0" marL="0">
+              <a:buNone/>
+            </a:pPr>
+            <a:r>
+              <a:rPr lang="en-US" sz="950" dirty="0">
+                <a:solidFill>
+                  <a:schemeClr val="accent5"/>
+                </a:solidFill>
+              </a:rPr>
+              <a:t>The quiz. Both questions optional, the whole step skippable.</a:t>
+            </a:r>
+            <a:endParaRPr lang="en-US" sz="950" dirty="0"/>
+          </a:p>
+        </p:txBody>
+      </p:sp>
+      <p:pic>
+        <p:nvPicPr>
+          <p:cNvPr id="5" name="Screenshot 2" descr="/home/claude/hybrid-movie-recommender/docs/screenshots/02-billboard-and-breakdown.jpg">    </p:cNvPr>
+          <p:cNvPicPr>
+            <a:picLocks noChangeAspect="1"/>
+          </p:cNvPicPr>
+          <p:nvPr/>
+        </p:nvPicPr>
+        <p:blipFill>
+          <a:blip r:embed="rId2"/>
+          <a:stretch>
+            <a:fillRect/>
+          </a:stretch>
+        </p:blipFill>
+        <p:spPr>
+          <a:xfrm>
+            <a:off x="4754880" y="1078992"/>
+            <a:ext cx="3456432" cy="1463040"/>
+          </a:xfrm>
+          <a:prstGeom prst="rect">
+            <a:avLst/>
+          </a:prstGeom>
+        </p:spPr>
+      </p:pic>
+      <p:sp>
+        <p:nvSpPr>
+          <p:cNvPr id="6" name="Text 2"/>
+          <p:cNvSpPr txBox="1"/>
+          <p:nvPr/>
+        </p:nvSpPr>
+        <p:spPr>
+          <a:xfrm>
+            <a:off x="4754880" y="2569464"/>
+            <a:ext cx="3456432" cy="274320"/>
+          </a:xfrm>
+          <a:prstGeom prst="rect">
+            <a:avLst/>
+          </a:prstGeom>
+          <a:noFill/>
+          <a:ln/>
+        </p:spPr>
+        <p:txBody>
+          <a:bodyPr wrap="square" lIns="0" tIns="0" rIns="0" bIns="0" rtlCol="0" anchor="t"/>
+          <a:lstStyle/>
+          <a:p>
+            <a:pPr indent="0" marL="0">
+              <a:buNone/>
+            </a:pPr>
+            <a:r>
+              <a:rPr lang="en-US" sz="950" dirty="0">
+                <a:solidFill>
+                  <a:schemeClr val="accent5"/>
+                </a:solidFill>
+              </a:rPr>
+              <a:t>Top pick with its reason and the score breakdown open.</a:t>
+            </a:r>
+            <a:endParaRPr lang="en-US" sz="950" dirty="0"/>
+          </a:p>
+        </p:txBody>
+      </p:sp>
+      <p:pic>
+        <p:nvPicPr>
+          <p:cNvPr id="7" name="Screenshot 3" descr="/home/claude/hybrid-movie-recommender/docs/screenshots/03-poster-row.jpg">    </p:cNvPr>
+          <p:cNvPicPr>
+            <a:picLocks noChangeAspect="1"/>
+          </p:cNvPicPr>
+          <p:nvPr/>
+        </p:nvPicPr>
+        <p:blipFill>
+          <a:blip r:embed="rId3"/>
+          <a:stretch>
+            <a:fillRect/>
+          </a:stretch>
+        </p:blipFill>
+        <p:spPr>
+          <a:xfrm>
+            <a:off x="640080" y="2944368"/>
+            <a:ext cx="3456432" cy="1463040"/>
+          </a:xfrm>
+          <a:prstGeom prst="rect">
+            <a:avLst/>
+          </a:prstGeom>
+        </p:spPr>
+      </p:pic>
+      <p:sp>
+        <p:nvSpPr>
+          <p:cNvPr id="8" name="Text 3"/>
+          <p:cNvSpPr txBox="1"/>
+          <p:nvPr/>
+        </p:nvSpPr>
+        <p:spPr>
+          <a:xfrm>
+            <a:off x="640080" y="4434840"/>
+            <a:ext cx="3456432" cy="274320"/>
+          </a:xfrm>
+          <a:prstGeom prst="rect">
+            <a:avLst/>
+          </a:prstGeom>
+          <a:noFill/>
+          <a:ln/>
+        </p:spPr>
+        <p:txBody>
+          <a:bodyPr wrap="square" lIns="0" tIns="0" rIns="0" bIns="0" rtlCol="0" anchor="t"/>
+          <a:lstStyle/>
+          <a:p>
+            <a:pPr indent="0" marL="0">
+              <a:buNone/>
+            </a:pPr>
+            <a:r>
+              <a:rPr lang="en-US" sz="950" dirty="0">
+                <a:solidFill>
+                  <a:schemeClr val="accent5"/>
+                </a:solidFill>
+              </a:rPr>
+              <a:t>A row of picks. Each card carries the reason it is there.</a:t>
+            </a:r>
+            <a:endParaRPr lang="en-US" sz="950" dirty="0"/>
+          </a:p>
+        </p:txBody>
+      </p:sp>
+      <p:pic>
+        <p:nvPicPr>
+          <p:cNvPr id="9" name="Screenshot 4" descr="/home/claude/hybrid-movie-recommender/docs/screenshots/04-how-it-works.jpg">    </p:cNvPr>
+          <p:cNvPicPr>
+            <a:picLocks noChangeAspect="1"/>
+          </p:cNvPicPr>
+          <p:nvPr/>
+        </p:nvPicPr>
+        <p:blipFill>
+          <a:blip r:embed="rId4"/>
+          <a:stretch>
+            <a:fillRect/>
+          </a:stretch>
+        </p:blipFill>
+        <p:spPr>
+          <a:xfrm>
+            <a:off x="4754880" y="2944368"/>
+            <a:ext cx="3456432" cy="1463040"/>
+          </a:xfrm>
+          <a:prstGeom prst="rect">
+            <a:avLst/>
+          </a:prstGeom>
+        </p:spPr>
+      </p:pic>
+      <p:sp>
+        <p:nvSpPr>
+          <p:cNvPr id="10" name="Text 4"/>
+          <p:cNvSpPr txBox="1"/>
+          <p:nvPr/>
+        </p:nvSpPr>
+        <p:spPr>
+          <a:xfrm>
+            <a:off x="4754880" y="4434840"/>
+            <a:ext cx="3456432" cy="274320"/>
+          </a:xfrm>
+          <a:prstGeom prst="rect">
+            <a:avLst/>
+          </a:prstGeom>
+          <a:noFill/>
+          <a:ln/>
+        </p:spPr>
+        <p:txBody>
+          <a:bodyPr wrap="square" lIns="0" tIns="0" rIns="0" bIns="0" rtlCol="0" anchor="t"/>
+          <a:lstStyle/>
+          <a:p>
+            <a:pPr indent="0" marL="0">
+              <a:buNone/>
+            </a:pPr>
+            <a:r>
+              <a:rPr lang="en-US" sz="950" dirty="0">
+                <a:solidFill>
+                  <a:schemeClr val="accent5"/>
+                </a:solidFill>
+              </a:rPr>
+              <a:t>The app shows its own offline evaluation.</a:t>
+            </a:r>
+            <a:endParaRPr lang="en-US" sz="950" dirty="0"/>
+          </a:p>
+        </p:txBody>
+      </p:sp>
+      <p:sp>
+        <p:nvSpPr>
+          <p:cNvPr id="25" name="Slide Number Placeholder 0"/>
+          <p:cNvSpPr>
+            <a:spLocks noGrp="1"/>
+          </p:cNvSpPr>
+          <p:nvPr>
+            <p:ph type="sldNum" sz="quarter" idx="4294967295"/>
+          </p:nvPr>
+        </p:nvSpPr>
+        <p:spPr>
+          <a:xfrm>
+            <a:off x="8229600" y="4754880"/>
+            <a:ext cx="457200" cy="274320"/>
+          </a:xfrm>
+          <a:prstGeom prst="rect">
+            <a:avLst/>
+          </a:prstGeom>
+          <a:extLst>
+            <a:ext uri="{C572A759-6A51-4108-AA02-DFA0A04FC94B}">
+              <ma14:wrappingTextBoxFlag xmlns:ma14="http://schemas.microsoft.com/office/mac/drawingml/2011/main" val="0"/>
+            </a:ext>
+          </a:extLst>
+        </p:spPr>
+        <p:txBody>
+          <a:bodyPr/>
+          <a:lstStyle>
+            <a:lvl1pPr>
+              <a:defRPr sz="1000">
+                <a:solidFill>
+                  <a:schemeClr val="accent5"/>
+                </a:solidFill>
+              </a:defRPr>
+            </a:lvl1pPr>
+          </a:lstStyle>
+          <a:p>
+            <a:pPr algn="r"/>
+            <a:fld id="{F7021451-1387-4CA6-816F-3879F97B5CBC}" type="slidenum">
+              <a:rPr b="0" lang="en-US"/>
+              <a:t>11</a:t>
+            </a:fld>
+            <a:endParaRPr lang="en-US"/>
+          </a:p>
+        </p:txBody>
+      </p:sp>
+    </p:spTree>
+  </p:cSld>
+  <p:clrMapOvr>
+    <a:masterClrMapping/>
+  </p:clrMapOvr>
+</p:sld>
+</file>
+
+<file path=ppt/slides/slide12.xml><?xml version="1.0" encoding="utf-8"?>
+<p:sld xmlns:a="http://schemas.openxmlformats.org/drawingml/2006/main" xmlns:r="http://schemas.openxmlformats.org/officeDocument/2006/relationships" xmlns:p="http://schemas.openxmlformats.org/presentationml/2006/main">
+  <p:cSld name="Slide 12">
+    <p:spTree>
+      <p:nvGrpSpPr>
+        <p:cNvPr id="1" name=""/>
+        <p:cNvGrpSpPr/>
+        <p:nvPr/>
+      </p:nvGrpSpPr>
+      <p:grpSpPr>
+        <a:xfrm>
+          <a:off x="0" y="0"/>
+          <a:ext cx="0" cy="0"/>
+          <a:chOff x="0" y="0"/>
+          <a:chExt cx="0" cy="0"/>
+        </a:xfrm>
+      </p:grpSpPr>
+      <p:sp>
+        <p:nvSpPr>
+          <p:cNvPr id="2" name="Text 0"/>
+          <p:cNvSpPr/>
+          <p:nvPr>
+            <p:ph idx="100" type="title" hasCustomPrompt="1"/>
+          </p:nvPr>
+        </p:nvSpPr>
+        <p:spPr>
+          <a:xfrm>
+            <a:off x="457200" y="274320"/>
+            <a:ext cx="8229600" cy="731520"/>
+          </a:xfrm>
+          <a:prstGeom prst="rect">
+            <a:avLst/>
+          </a:prstGeom>
+          <a:noFill/>
+          <a:ln/>
+        </p:spPr>
+        <p:txBody>
+          <a:bodyPr wrap="square" lIns="0" tIns="0" rIns="0" bIns="0" rtlCol="0" anchor="ctr"/>
+          <a:lstStyle/>
+          <a:p>
+            <a:pPr algn="l" indent="0" marL="0">
+              <a:buNone/>
+            </a:pPr>
+            <a:r>
+              <a:rPr lang="en-US" sz="3200" b="1" dirty="0">
+                <a:solidFill>
+                  <a:schemeClr val="tx2"/>
+                </a:solidFill>
+              </a:rPr>
               <a:t>Limits and next steps</a:t>
             </a:r>
             <a:endParaRPr lang="en-US" sz="3200" dirty="0"/>
@@ -4537,7 +4975,7 @@
             <a:pPr algn="r"/>
             <a:fld id="{F7021451-1387-4CA6-816F-3879F97B5CBC}" type="slidenum">
               <a:rPr b="0" lang="en-US"/>
-              <a:t>11</a:t>
+              <a:t>12</a:t>
             </a:fld>
             <a:endParaRPr lang="en-US"/>
           </a:p>
@@ -4551,9 +4989,9 @@
 </p:sld>
 </file>
 
-<file path=ppt/slides/slide12.xml><?xml version="1.0" encoding="utf-8"?>
+<file path=ppt/slides/slide13.xml><?xml version="1.0" encoding="utf-8"?>
 <p:sld xmlns:a="http://schemas.openxmlformats.org/drawingml/2006/main" xmlns:r="http://schemas.openxmlformats.org/officeDocument/2006/relationships" xmlns:p="http://schemas.openxmlformats.org/presentationml/2006/main">
-  <p:cSld name="Slide 12">
+  <p:cSld name="Slide 13">
     <p:spTree>
       <p:nvGrpSpPr>
         <p:cNvPr id="1" name=""/>

</xml_diff>